<commit_message>
Materialien neu gebaut (D15): Akten, Lösungen, Präsentationen, Lehrerhinweise, Warm-up W3
Gebaut mit bauen.py aus den geänderten Quellen, PDFs mit npm run akten,
loesungen und lehrkraft; nicht betroffene PDFs unverändert gelassen.

Co-Authored-By: Claude Opus 5.5 <noreply@anthropic.com>
Claude-Session: https://claude.ai/code/session_01JKXVQqFeKVmyQ9jfHw4db3
</commit_message>
<xml_diff>
--- a/materialien/Welt1_Bagdad/1_Praesentation/KR_W1_Praesentation_Bagdad.pptx
+++ b/materialien/Welt1_Bagdad/1_Praesentation/KR_W1_Praesentation_Bagdad.pptx
@@ -135,7 +135,7 @@
   <p:extLst>
     <p:ext uri="{521415D9-36F7-43E2-AB2F-B90AF26B5E84}">
       <p14:sectionLst xmlns:p14="http://schemas.microsoft.com/office/powerpoint/2010/main">
-        <p14:section name="DS 4 · Al-Kindis Handschrift" id="{1e8007c1-0b6f-0a48-b701-e275e6203b83}">
+        <p14:section name="DS 4 · Al-Kindis Handschrift" id="{d46d2414-ad06-5245-f291-9fc3c39eda4a}">
           <p14:sldIdLst>
             <p14:sldId id="256"/>
             <p14:sldId id="257"/>
@@ -154,7 +154,7 @@
             <p14:sldId id="270"/>
           </p14:sldIdLst>
         </p14:section>
-        <p14:section name="DS 5 · Die Gegenmittel" id="{397b0c31-124c-d3b2-7748-55cc2796113e}">
+        <p14:section name="DS 5 · Die Gegenmittel" id="{3f784313-5bf8-0021-52c6-e8d80adae119}">
           <p14:sldIdLst>
             <p14:sldId id="271"/>
             <p14:sldId id="272"/>
@@ -168,7 +168,7 @@
             <p14:sldId id="280"/>
           </p14:sldIdLst>
         </p14:section>
-        <p14:section name="DS 5 · Der Nomenklator" id="{cc126d35-daa3-d045-1c01-b5b63fec721e}">
+        <p14:section name="DS 5 · Der Nomenklator" id="{1f8db697-d94a-e850-5749-f0ac2a6bd310}">
           <p14:sldIdLst>
             <p14:sldId id="281"/>
             <p14:sldId id="282"/>
@@ -2804,7 +2804,7 @@
           <a:p>
             <a:r>
               <a:rPr lang="en-US" dirty="0"/>
-              <a:t>5 min. Archivfund vorlesen: „Das Chronoskop zeigt ‚850‘. Vor dir liegt ein Blatt aus dem Haus der Weisheit, beschrieben mit einer fremden Buchstabenfolge. Diesmal ist nicht verschoben wie bei Caesar: Jeder Buchstabe wurde durch einen beliebigen anderen ersetzt. 26! Möglichkeiten – mehr, als ein Mensch je ausprobieren könnte. Am Rand steht in arabischer Schrift eine Notiz, die das Archiv übersetzt hat: ‚Wer die Zeichen zählt, braucht keinen Schlüssel.‘ Am Ende dieser Stunde wirst du die Botschaft lesen können.“
+              <a:t>5 min. Archivfund vorlesen: „Das Chronoskop zeigt ‚850‘. Vor dir liegt ein Blatt aus dem Haus der Weisheit, beschrieben mit einer fremden Buchstabenfolge. Diesmal ist nicht verschoben wie bei Caesar: Jeder Buchstabe wurde durch einen beliebigen anderen ersetzt. 26! Möglichkeiten – mehr, als ein Mensch je ausprobieren könnte. Am Rand steht in arabischer Schrift eine Notiz, die das Archiv übersetzt hat: ‚Wer die Häufigkeiten kennt, liest jedes Blatt.‘ Am Ende dieser Stunde wirst du die Botschaft lesen können.“
 Impuls: Chiffrierscheibe aus Welt 0 probieren lassen – keine Verschiebung passt (z. B. U ist 9 × da; als e gedeutet ergäbe sich Verschiebung 16, dann wird aus ZPUCG kein Wort).
 Nur Lehrkraft: Lösung „zaehle die zeichen und du findest den schluessel“, Schlüsselwort PAPYRUS – derselbe Schlüssel wie im Wettknacken. Nicht verraten; Auflösung auf Folie 15.</a:t>
             </a:r>
@@ -15510,7 +15510,7 @@
                   <a:srgbClr val="FBF7EE"/>
                 </a:solidFill>
               </a:rPr>
-              <a:t>„Wer die Zeichen zählt, braucht keinen Schlüssel.“</a:t>
+              <a:t>„Wer die Häufigkeiten kennt, liest jedes Blatt.“</a:t>
             </a:r>
             <a:endParaRPr lang="en-US" sz="2200" dirty="0"/>
           </a:p>
@@ -16480,1830 +16480,6 @@
           </a:p>
         </p:txBody>
       </p:sp>
-      <p:graphicFrame>
-        <p:nvGraphicFramePr>
-          <p:cNvPr id="41" name="Table 1"/>
-          <p:cNvGraphicFramePr>
-            <a:graphicFrameLocks noGrp="1"/>
-          </p:cNvGraphicFramePr>
-          <p:nvPr>
-            <p:extLst>
-              <p:ext uri="{D42A27DB-BD31-4B8C-83A1-F6EECF244321}">
-                <p14:modId xmlns:p14="http://schemas.microsoft.com/office/powerpoint/2010/main" val="1579011935"/>
-              </p:ext>
-            </p:extLst>
-          </p:nvPr>
-        </p:nvGraphicFramePr>
-        <p:xfrm>
-          <a:off x="548640" y="2771140"/>
-          <a:ext cx="11094415" cy="914400"/>
-        </p:xfrm>
-        <a:graphic>
-          <a:graphicData uri="http://schemas.openxmlformats.org/drawingml/2006/table">
-            <a:tbl>
-              <a:tblPr/>
-              <a:tblGrid>
-                <a:gridCol w="853417"/>
-                <a:gridCol w="853417"/>
-                <a:gridCol w="853417"/>
-                <a:gridCol w="853417"/>
-                <a:gridCol w="853417"/>
-                <a:gridCol w="853417"/>
-                <a:gridCol w="853417"/>
-                <a:gridCol w="853417"/>
-                <a:gridCol w="853417"/>
-                <a:gridCol w="853417"/>
-                <a:gridCol w="853417"/>
-                <a:gridCol w="853417"/>
-                <a:gridCol w="853417"/>
-              </a:tblGrid>
-              <a:tr h="0">
-                <a:tc>
-                  <a:txBody>
-                    <a:bodyPr/>
-                    <a:lstStyle/>
-                    <a:p>
-                      <a:pPr algn="ctr" indent="0" marL="0">
-                        <a:buNone/>
-                      </a:pPr>
-                      <a:r>
-                        <a:rPr lang="en-US" sz="1600" b="1" dirty="0">
-                          <a:solidFill>
-                            <a:srgbClr val="1B1B1F"/>
-                          </a:solidFill>
-                          <a:latin typeface="Calibri" pitchFamily="34" charset="0"/>
-                          <a:ea typeface="Calibri" pitchFamily="34" charset="-122"/>
-                          <a:cs typeface="Calibri" pitchFamily="34" charset="-120"/>
-                        </a:rPr>
-                        <a:t>m</a:t>
-                      </a:r>
-                      <a:endParaRPr lang="en-US" sz="1600" dirty="0">
-                        <a:latin typeface="Calibri" charset="0"/>
-                        <a:ea typeface="Calibri" charset="0"/>
-                        <a:cs typeface="Calibri" charset="0"/>
-                      </a:endParaRPr>
-                    </a:p>
-                  </a:txBody>
-                  <a:tcPr marL="64008" marR="64008" marT="36576" marB="36576" anchor="ctr">
-                    <a:lnL w="9525" cap="flat" cmpd="sng" algn="ctr">
-                      <a:solidFill>
-                        <a:srgbClr val="D8CDB8"/>
-                      </a:solidFill>
-                      <a:prstDash val="solid"/>
-                      <a:round/>
-                      <a:headEnd type="none" w="med" len="med"/>
-                      <a:tailEnd type="none" w="med" len="med"/>
-                    </a:lnL>
-                    <a:lnR w="9525" cap="flat" cmpd="sng" algn="ctr">
-                      <a:solidFill>
-                        <a:srgbClr val="D8CDB8"/>
-                      </a:solidFill>
-                      <a:prstDash val="solid"/>
-                      <a:round/>
-                      <a:headEnd type="none" w="med" len="med"/>
-                      <a:tailEnd type="none" w="med" len="med"/>
-                    </a:lnR>
-                    <a:lnT w="9525" cap="flat" cmpd="sng" algn="ctr">
-                      <a:solidFill>
-                        <a:srgbClr val="D8CDB8"/>
-                      </a:solidFill>
-                      <a:prstDash val="solid"/>
-                      <a:round/>
-                      <a:headEnd type="none" w="med" len="med"/>
-                      <a:tailEnd type="none" w="med" len="med"/>
-                    </a:lnT>
-                    <a:lnB w="9525" cap="flat" cmpd="sng" algn="ctr">
-                      <a:solidFill>
-                        <a:srgbClr val="D8CDB8"/>
-                      </a:solidFill>
-                      <a:prstDash val="solid"/>
-                      <a:round/>
-                      <a:headEnd type="none" w="med" len="med"/>
-                      <a:tailEnd type="none" w="med" len="med"/>
-                    </a:lnB>
-                    <a:solidFill>
-                      <a:srgbClr val="F2EADB"/>
-                    </a:solidFill>
-                  </a:tcPr>
-                </a:tc>
-                <a:tc>
-                  <a:txBody>
-                    <a:bodyPr/>
-                    <a:lstStyle/>
-                    <a:p>
-                      <a:pPr algn="ctr" indent="0" marL="0">
-                        <a:buNone/>
-                      </a:pPr>
-                      <a:r>
-                        <a:rPr lang="en-US" sz="1600" dirty="0">
-                          <a:solidFill>
-                            <a:srgbClr val="1B1B1F"/>
-                          </a:solidFill>
-                          <a:latin typeface="Calibri" pitchFamily="34" charset="0"/>
-                          <a:ea typeface="Calibri" pitchFamily="34" charset="-122"/>
-                          <a:cs typeface="Calibri" pitchFamily="34" charset="-120"/>
-                        </a:rPr>
-                        <a:t>1</a:t>
-                      </a:r>
-                      <a:endParaRPr lang="en-US" sz="1600" dirty="0">
-                        <a:latin typeface="Calibri" charset="0"/>
-                        <a:ea typeface="Calibri" charset="0"/>
-                        <a:cs typeface="Calibri" charset="0"/>
-                      </a:endParaRPr>
-                    </a:p>
-                  </a:txBody>
-                  <a:tcPr marL="64008" marR="64008" marT="36576" marB="36576" anchor="ctr">
-                    <a:lnL w="9525" cap="flat" cmpd="sng" algn="ctr">
-                      <a:solidFill>
-                        <a:srgbClr val="D8CDB8"/>
-                      </a:solidFill>
-                      <a:prstDash val="solid"/>
-                      <a:round/>
-                      <a:headEnd type="none" w="med" len="med"/>
-                      <a:tailEnd type="none" w="med" len="med"/>
-                    </a:lnL>
-                    <a:lnR w="9525" cap="flat" cmpd="sng" algn="ctr">
-                      <a:solidFill>
-                        <a:srgbClr val="D8CDB8"/>
-                      </a:solidFill>
-                      <a:prstDash val="solid"/>
-                      <a:round/>
-                      <a:headEnd type="none" w="med" len="med"/>
-                      <a:tailEnd type="none" w="med" len="med"/>
-                    </a:lnR>
-                    <a:lnT w="9525" cap="flat" cmpd="sng" algn="ctr">
-                      <a:solidFill>
-                        <a:srgbClr val="D8CDB8"/>
-                      </a:solidFill>
-                      <a:prstDash val="solid"/>
-                      <a:round/>
-                      <a:headEnd type="none" w="med" len="med"/>
-                      <a:tailEnd type="none" w="med" len="med"/>
-                    </a:lnT>
-                    <a:lnB w="9525" cap="flat" cmpd="sng" algn="ctr">
-                      <a:solidFill>
-                        <a:srgbClr val="D8CDB8"/>
-                      </a:solidFill>
-                      <a:prstDash val="solid"/>
-                      <a:round/>
-                      <a:headEnd type="none" w="med" len="med"/>
-                      <a:tailEnd type="none" w="med" len="med"/>
-                    </a:lnB>
-                    <a:solidFill>
-                      <a:srgbClr val="FFFFFF"/>
-                    </a:solidFill>
-                  </a:tcPr>
-                </a:tc>
-                <a:tc>
-                  <a:txBody>
-                    <a:bodyPr/>
-                    <a:lstStyle/>
-                    <a:p>
-                      <a:pPr algn="ctr" indent="0" marL="0">
-                        <a:buNone/>
-                      </a:pPr>
-                      <a:r>
-                        <a:rPr lang="en-US" sz="1600" dirty="0">
-                          <a:solidFill>
-                            <a:srgbClr val="1B1B1F"/>
-                          </a:solidFill>
-                          <a:latin typeface="Calibri" pitchFamily="34" charset="0"/>
-                          <a:ea typeface="Calibri" pitchFamily="34" charset="-122"/>
-                          <a:cs typeface="Calibri" pitchFamily="34" charset="-120"/>
-                        </a:rPr>
-                        <a:t>3</a:t>
-                      </a:r>
-                      <a:endParaRPr lang="en-US" sz="1600" dirty="0">
-                        <a:latin typeface="Calibri" charset="0"/>
-                        <a:ea typeface="Calibri" charset="0"/>
-                        <a:cs typeface="Calibri" charset="0"/>
-                      </a:endParaRPr>
-                    </a:p>
-                  </a:txBody>
-                  <a:tcPr marL="64008" marR="64008" marT="36576" marB="36576" anchor="ctr">
-                    <a:lnL w="9525" cap="flat" cmpd="sng" algn="ctr">
-                      <a:solidFill>
-                        <a:srgbClr val="D8CDB8"/>
-                      </a:solidFill>
-                      <a:prstDash val="solid"/>
-                      <a:round/>
-                      <a:headEnd type="none" w="med" len="med"/>
-                      <a:tailEnd type="none" w="med" len="med"/>
-                    </a:lnL>
-                    <a:lnR w="9525" cap="flat" cmpd="sng" algn="ctr">
-                      <a:solidFill>
-                        <a:srgbClr val="D8CDB8"/>
-                      </a:solidFill>
-                      <a:prstDash val="solid"/>
-                      <a:round/>
-                      <a:headEnd type="none" w="med" len="med"/>
-                      <a:tailEnd type="none" w="med" len="med"/>
-                    </a:lnR>
-                    <a:lnT w="9525" cap="flat" cmpd="sng" algn="ctr">
-                      <a:solidFill>
-                        <a:srgbClr val="D8CDB8"/>
-                      </a:solidFill>
-                      <a:prstDash val="solid"/>
-                      <a:round/>
-                      <a:headEnd type="none" w="med" len="med"/>
-                      <a:tailEnd type="none" w="med" len="med"/>
-                    </a:lnT>
-                    <a:lnB w="9525" cap="flat" cmpd="sng" algn="ctr">
-                      <a:solidFill>
-                        <a:srgbClr val="D8CDB8"/>
-                      </a:solidFill>
-                      <a:prstDash val="solid"/>
-                      <a:round/>
-                      <a:headEnd type="none" w="med" len="med"/>
-                      <a:tailEnd type="none" w="med" len="med"/>
-                    </a:lnB>
-                    <a:solidFill>
-                      <a:srgbClr val="FFFFFF"/>
-                    </a:solidFill>
-                  </a:tcPr>
-                </a:tc>
-                <a:tc>
-                  <a:txBody>
-                    <a:bodyPr/>
-                    <a:lstStyle/>
-                    <a:p>
-                      <a:pPr algn="ctr" indent="0" marL="0">
-                        <a:buNone/>
-                      </a:pPr>
-                      <a:r>
-                        <a:rPr lang="en-US" sz="1600" dirty="0">
-                          <a:solidFill>
-                            <a:srgbClr val="1B1B1F"/>
-                          </a:solidFill>
-                          <a:latin typeface="Calibri" pitchFamily="34" charset="0"/>
-                          <a:ea typeface="Calibri" pitchFamily="34" charset="-122"/>
-                          <a:cs typeface="Calibri" pitchFamily="34" charset="-120"/>
-                        </a:rPr>
-                        <a:t>5</a:t>
-                      </a:r>
-                      <a:endParaRPr lang="en-US" sz="1600" dirty="0">
-                        <a:latin typeface="Calibri" charset="0"/>
-                        <a:ea typeface="Calibri" charset="0"/>
-                        <a:cs typeface="Calibri" charset="0"/>
-                      </a:endParaRPr>
-                    </a:p>
-                  </a:txBody>
-                  <a:tcPr marL="64008" marR="64008" marT="36576" marB="36576" anchor="ctr">
-                    <a:lnL w="9525" cap="flat" cmpd="sng" algn="ctr">
-                      <a:solidFill>
-                        <a:srgbClr val="D8CDB8"/>
-                      </a:solidFill>
-                      <a:prstDash val="solid"/>
-                      <a:round/>
-                      <a:headEnd type="none" w="med" len="med"/>
-                      <a:tailEnd type="none" w="med" len="med"/>
-                    </a:lnL>
-                    <a:lnR w="9525" cap="flat" cmpd="sng" algn="ctr">
-                      <a:solidFill>
-                        <a:srgbClr val="D8CDB8"/>
-                      </a:solidFill>
-                      <a:prstDash val="solid"/>
-                      <a:round/>
-                      <a:headEnd type="none" w="med" len="med"/>
-                      <a:tailEnd type="none" w="med" len="med"/>
-                    </a:lnR>
-                    <a:lnT w="9525" cap="flat" cmpd="sng" algn="ctr">
-                      <a:solidFill>
-                        <a:srgbClr val="D8CDB8"/>
-                      </a:solidFill>
-                      <a:prstDash val="solid"/>
-                      <a:round/>
-                      <a:headEnd type="none" w="med" len="med"/>
-                      <a:tailEnd type="none" w="med" len="med"/>
-                    </a:lnT>
-                    <a:lnB w="9525" cap="flat" cmpd="sng" algn="ctr">
-                      <a:solidFill>
-                        <a:srgbClr val="D8CDB8"/>
-                      </a:solidFill>
-                      <a:prstDash val="solid"/>
-                      <a:round/>
-                      <a:headEnd type="none" w="med" len="med"/>
-                      <a:tailEnd type="none" w="med" len="med"/>
-                    </a:lnB>
-                    <a:solidFill>
-                      <a:srgbClr val="FFFFFF"/>
-                    </a:solidFill>
-                  </a:tcPr>
-                </a:tc>
-                <a:tc>
-                  <a:txBody>
-                    <a:bodyPr/>
-                    <a:lstStyle/>
-                    <a:p>
-                      <a:pPr algn="ctr" indent="0" marL="0">
-                        <a:buNone/>
-                      </a:pPr>
-                      <a:r>
-                        <a:rPr lang="en-US" sz="1600" dirty="0">
-                          <a:solidFill>
-                            <a:srgbClr val="1B1B1F"/>
-                          </a:solidFill>
-                          <a:latin typeface="Calibri" pitchFamily="34" charset="0"/>
-                          <a:ea typeface="Calibri" pitchFamily="34" charset="-122"/>
-                          <a:cs typeface="Calibri" pitchFamily="34" charset="-120"/>
-                        </a:rPr>
-                        <a:t>7</a:t>
-                      </a:r>
-                      <a:endParaRPr lang="en-US" sz="1600" dirty="0">
-                        <a:latin typeface="Calibri" charset="0"/>
-                        <a:ea typeface="Calibri" charset="0"/>
-                        <a:cs typeface="Calibri" charset="0"/>
-                      </a:endParaRPr>
-                    </a:p>
-                  </a:txBody>
-                  <a:tcPr marL="64008" marR="64008" marT="36576" marB="36576" anchor="ctr">
-                    <a:lnL w="9525" cap="flat" cmpd="sng" algn="ctr">
-                      <a:solidFill>
-                        <a:srgbClr val="D8CDB8"/>
-                      </a:solidFill>
-                      <a:prstDash val="solid"/>
-                      <a:round/>
-                      <a:headEnd type="none" w="med" len="med"/>
-                      <a:tailEnd type="none" w="med" len="med"/>
-                    </a:lnL>
-                    <a:lnR w="9525" cap="flat" cmpd="sng" algn="ctr">
-                      <a:solidFill>
-                        <a:srgbClr val="D8CDB8"/>
-                      </a:solidFill>
-                      <a:prstDash val="solid"/>
-                      <a:round/>
-                      <a:headEnd type="none" w="med" len="med"/>
-                      <a:tailEnd type="none" w="med" len="med"/>
-                    </a:lnR>
-                    <a:lnT w="9525" cap="flat" cmpd="sng" algn="ctr">
-                      <a:solidFill>
-                        <a:srgbClr val="D8CDB8"/>
-                      </a:solidFill>
-                      <a:prstDash val="solid"/>
-                      <a:round/>
-                      <a:headEnd type="none" w="med" len="med"/>
-                      <a:tailEnd type="none" w="med" len="med"/>
-                    </a:lnT>
-                    <a:lnB w="9525" cap="flat" cmpd="sng" algn="ctr">
-                      <a:solidFill>
-                        <a:srgbClr val="D8CDB8"/>
-                      </a:solidFill>
-                      <a:prstDash val="solid"/>
-                      <a:round/>
-                      <a:headEnd type="none" w="med" len="med"/>
-                      <a:tailEnd type="none" w="med" len="med"/>
-                    </a:lnB>
-                    <a:solidFill>
-                      <a:srgbClr val="FFFFFF"/>
-                    </a:solidFill>
-                  </a:tcPr>
-                </a:tc>
-                <a:tc>
-                  <a:txBody>
-                    <a:bodyPr/>
-                    <a:lstStyle/>
-                    <a:p>
-                      <a:pPr algn="ctr" indent="0" marL="0">
-                        <a:buNone/>
-                      </a:pPr>
-                      <a:r>
-                        <a:rPr lang="en-US" sz="1600" dirty="0">
-                          <a:solidFill>
-                            <a:srgbClr val="1B1B1F"/>
-                          </a:solidFill>
-                          <a:latin typeface="Calibri" pitchFamily="34" charset="0"/>
-                          <a:ea typeface="Calibri" pitchFamily="34" charset="-122"/>
-                          <a:cs typeface="Calibri" pitchFamily="34" charset="-120"/>
-                        </a:rPr>
-                        <a:t>9</a:t>
-                      </a:r>
-                      <a:endParaRPr lang="en-US" sz="1600" dirty="0">
-                        <a:latin typeface="Calibri" charset="0"/>
-                        <a:ea typeface="Calibri" charset="0"/>
-                        <a:cs typeface="Calibri" charset="0"/>
-                      </a:endParaRPr>
-                    </a:p>
-                  </a:txBody>
-                  <a:tcPr marL="64008" marR="64008" marT="36576" marB="36576" anchor="ctr">
-                    <a:lnL w="9525" cap="flat" cmpd="sng" algn="ctr">
-                      <a:solidFill>
-                        <a:srgbClr val="D8CDB8"/>
-                      </a:solidFill>
-                      <a:prstDash val="solid"/>
-                      <a:round/>
-                      <a:headEnd type="none" w="med" len="med"/>
-                      <a:tailEnd type="none" w="med" len="med"/>
-                    </a:lnL>
-                    <a:lnR w="9525" cap="flat" cmpd="sng" algn="ctr">
-                      <a:solidFill>
-                        <a:srgbClr val="D8CDB8"/>
-                      </a:solidFill>
-                      <a:prstDash val="solid"/>
-                      <a:round/>
-                      <a:headEnd type="none" w="med" len="med"/>
-                      <a:tailEnd type="none" w="med" len="med"/>
-                    </a:lnR>
-                    <a:lnT w="9525" cap="flat" cmpd="sng" algn="ctr">
-                      <a:solidFill>
-                        <a:srgbClr val="D8CDB8"/>
-                      </a:solidFill>
-                      <a:prstDash val="solid"/>
-                      <a:round/>
-                      <a:headEnd type="none" w="med" len="med"/>
-                      <a:tailEnd type="none" w="med" len="med"/>
-                    </a:lnT>
-                    <a:lnB w="9525" cap="flat" cmpd="sng" algn="ctr">
-                      <a:solidFill>
-                        <a:srgbClr val="D8CDB8"/>
-                      </a:solidFill>
-                      <a:prstDash val="solid"/>
-                      <a:round/>
-                      <a:headEnd type="none" w="med" len="med"/>
-                      <a:tailEnd type="none" w="med" len="med"/>
-                    </a:lnB>
-                    <a:solidFill>
-                      <a:srgbClr val="FFFFFF"/>
-                    </a:solidFill>
-                  </a:tcPr>
-                </a:tc>
-                <a:tc>
-                  <a:txBody>
-                    <a:bodyPr/>
-                    <a:lstStyle/>
-                    <a:p>
-                      <a:pPr algn="ctr" indent="0" marL="0">
-                        <a:buNone/>
-                      </a:pPr>
-                      <a:r>
-                        <a:rPr lang="en-US" sz="1600" dirty="0">
-                          <a:solidFill>
-                            <a:srgbClr val="1B1B1F"/>
-                          </a:solidFill>
-                          <a:latin typeface="Calibri" pitchFamily="34" charset="0"/>
-                          <a:ea typeface="Calibri" pitchFamily="34" charset="-122"/>
-                          <a:cs typeface="Calibri" pitchFamily="34" charset="-120"/>
-                        </a:rPr>
-                        <a:t>11</a:t>
-                      </a:r>
-                      <a:endParaRPr lang="en-US" sz="1600" dirty="0">
-                        <a:latin typeface="Calibri" charset="0"/>
-                        <a:ea typeface="Calibri" charset="0"/>
-                        <a:cs typeface="Calibri" charset="0"/>
-                      </a:endParaRPr>
-                    </a:p>
-                  </a:txBody>
-                  <a:tcPr marL="64008" marR="64008" marT="36576" marB="36576" anchor="ctr">
-                    <a:lnL w="9525" cap="flat" cmpd="sng" algn="ctr">
-                      <a:solidFill>
-                        <a:srgbClr val="D8CDB8"/>
-                      </a:solidFill>
-                      <a:prstDash val="solid"/>
-                      <a:round/>
-                      <a:headEnd type="none" w="med" len="med"/>
-                      <a:tailEnd type="none" w="med" len="med"/>
-                    </a:lnL>
-                    <a:lnR w="9525" cap="flat" cmpd="sng" algn="ctr">
-                      <a:solidFill>
-                        <a:srgbClr val="D8CDB8"/>
-                      </a:solidFill>
-                      <a:prstDash val="solid"/>
-                      <a:round/>
-                      <a:headEnd type="none" w="med" len="med"/>
-                      <a:tailEnd type="none" w="med" len="med"/>
-                    </a:lnR>
-                    <a:lnT w="9525" cap="flat" cmpd="sng" algn="ctr">
-                      <a:solidFill>
-                        <a:srgbClr val="D8CDB8"/>
-                      </a:solidFill>
-                      <a:prstDash val="solid"/>
-                      <a:round/>
-                      <a:headEnd type="none" w="med" len="med"/>
-                      <a:tailEnd type="none" w="med" len="med"/>
-                    </a:lnT>
-                    <a:lnB w="9525" cap="flat" cmpd="sng" algn="ctr">
-                      <a:solidFill>
-                        <a:srgbClr val="D8CDB8"/>
-                      </a:solidFill>
-                      <a:prstDash val="solid"/>
-                      <a:round/>
-                      <a:headEnd type="none" w="med" len="med"/>
-                      <a:tailEnd type="none" w="med" len="med"/>
-                    </a:lnB>
-                    <a:solidFill>
-                      <a:srgbClr val="FFFFFF"/>
-                    </a:solidFill>
-                  </a:tcPr>
-                </a:tc>
-                <a:tc>
-                  <a:txBody>
-                    <a:bodyPr/>
-                    <a:lstStyle/>
-                    <a:p>
-                      <a:pPr algn="ctr" indent="0" marL="0">
-                        <a:buNone/>
-                      </a:pPr>
-                      <a:r>
-                        <a:rPr lang="en-US" sz="1600" dirty="0">
-                          <a:solidFill>
-                            <a:srgbClr val="1B1B1F"/>
-                          </a:solidFill>
-                          <a:latin typeface="Calibri" pitchFamily="34" charset="0"/>
-                          <a:ea typeface="Calibri" pitchFamily="34" charset="-122"/>
-                          <a:cs typeface="Calibri" pitchFamily="34" charset="-120"/>
-                        </a:rPr>
-                        <a:t>15</a:t>
-                      </a:r>
-                      <a:endParaRPr lang="en-US" sz="1600" dirty="0">
-                        <a:latin typeface="Calibri" charset="0"/>
-                        <a:ea typeface="Calibri" charset="0"/>
-                        <a:cs typeface="Calibri" charset="0"/>
-                      </a:endParaRPr>
-                    </a:p>
-                  </a:txBody>
-                  <a:tcPr marL="64008" marR="64008" marT="36576" marB="36576" anchor="ctr">
-                    <a:lnL w="9525" cap="flat" cmpd="sng" algn="ctr">
-                      <a:solidFill>
-                        <a:srgbClr val="D8CDB8"/>
-                      </a:solidFill>
-                      <a:prstDash val="solid"/>
-                      <a:round/>
-                      <a:headEnd type="none" w="med" len="med"/>
-                      <a:tailEnd type="none" w="med" len="med"/>
-                    </a:lnL>
-                    <a:lnR w="9525" cap="flat" cmpd="sng" algn="ctr">
-                      <a:solidFill>
-                        <a:srgbClr val="D8CDB8"/>
-                      </a:solidFill>
-                      <a:prstDash val="solid"/>
-                      <a:round/>
-                      <a:headEnd type="none" w="med" len="med"/>
-                      <a:tailEnd type="none" w="med" len="med"/>
-                    </a:lnR>
-                    <a:lnT w="9525" cap="flat" cmpd="sng" algn="ctr">
-                      <a:solidFill>
-                        <a:srgbClr val="D8CDB8"/>
-                      </a:solidFill>
-                      <a:prstDash val="solid"/>
-                      <a:round/>
-                      <a:headEnd type="none" w="med" len="med"/>
-                      <a:tailEnd type="none" w="med" len="med"/>
-                    </a:lnT>
-                    <a:lnB w="9525" cap="flat" cmpd="sng" algn="ctr">
-                      <a:solidFill>
-                        <a:srgbClr val="D8CDB8"/>
-                      </a:solidFill>
-                      <a:prstDash val="solid"/>
-                      <a:round/>
-                      <a:headEnd type="none" w="med" len="med"/>
-                      <a:tailEnd type="none" w="med" len="med"/>
-                    </a:lnB>
-                    <a:solidFill>
-                      <a:srgbClr val="FFFFFF"/>
-                    </a:solidFill>
-                  </a:tcPr>
-                </a:tc>
-                <a:tc>
-                  <a:txBody>
-                    <a:bodyPr/>
-                    <a:lstStyle/>
-                    <a:p>
-                      <a:pPr algn="ctr" indent="0" marL="0">
-                        <a:buNone/>
-                      </a:pPr>
-                      <a:r>
-                        <a:rPr lang="en-US" sz="1600" dirty="0">
-                          <a:solidFill>
-                            <a:srgbClr val="1B1B1F"/>
-                          </a:solidFill>
-                          <a:latin typeface="Calibri" pitchFamily="34" charset="0"/>
-                          <a:ea typeface="Calibri" pitchFamily="34" charset="-122"/>
-                          <a:cs typeface="Calibri" pitchFamily="34" charset="-120"/>
-                        </a:rPr>
-                        <a:t>17</a:t>
-                      </a:r>
-                      <a:endParaRPr lang="en-US" sz="1600" dirty="0">
-                        <a:latin typeface="Calibri" charset="0"/>
-                        <a:ea typeface="Calibri" charset="0"/>
-                        <a:cs typeface="Calibri" charset="0"/>
-                      </a:endParaRPr>
-                    </a:p>
-                  </a:txBody>
-                  <a:tcPr marL="64008" marR="64008" marT="36576" marB="36576" anchor="ctr">
-                    <a:lnL w="9525" cap="flat" cmpd="sng" algn="ctr">
-                      <a:solidFill>
-                        <a:srgbClr val="D8CDB8"/>
-                      </a:solidFill>
-                      <a:prstDash val="solid"/>
-                      <a:round/>
-                      <a:headEnd type="none" w="med" len="med"/>
-                      <a:tailEnd type="none" w="med" len="med"/>
-                    </a:lnL>
-                    <a:lnR w="9525" cap="flat" cmpd="sng" algn="ctr">
-                      <a:solidFill>
-                        <a:srgbClr val="D8CDB8"/>
-                      </a:solidFill>
-                      <a:prstDash val="solid"/>
-                      <a:round/>
-                      <a:headEnd type="none" w="med" len="med"/>
-                      <a:tailEnd type="none" w="med" len="med"/>
-                    </a:lnR>
-                    <a:lnT w="9525" cap="flat" cmpd="sng" algn="ctr">
-                      <a:solidFill>
-                        <a:srgbClr val="D8CDB8"/>
-                      </a:solidFill>
-                      <a:prstDash val="solid"/>
-                      <a:round/>
-                      <a:headEnd type="none" w="med" len="med"/>
-                      <a:tailEnd type="none" w="med" len="med"/>
-                    </a:lnT>
-                    <a:lnB w="9525" cap="flat" cmpd="sng" algn="ctr">
-                      <a:solidFill>
-                        <a:srgbClr val="D8CDB8"/>
-                      </a:solidFill>
-                      <a:prstDash val="solid"/>
-                      <a:round/>
-                      <a:headEnd type="none" w="med" len="med"/>
-                      <a:tailEnd type="none" w="med" len="med"/>
-                    </a:lnB>
-                    <a:solidFill>
-                      <a:srgbClr val="FFFFFF"/>
-                    </a:solidFill>
-                  </a:tcPr>
-                </a:tc>
-                <a:tc>
-                  <a:txBody>
-                    <a:bodyPr/>
-                    <a:lstStyle/>
-                    <a:p>
-                      <a:pPr algn="ctr" indent="0" marL="0">
-                        <a:buNone/>
-                      </a:pPr>
-                      <a:r>
-                        <a:rPr lang="en-US" sz="1600" dirty="0">
-                          <a:solidFill>
-                            <a:srgbClr val="1B1B1F"/>
-                          </a:solidFill>
-                          <a:latin typeface="Calibri" pitchFamily="34" charset="0"/>
-                          <a:ea typeface="Calibri" pitchFamily="34" charset="-122"/>
-                          <a:cs typeface="Calibri" pitchFamily="34" charset="-120"/>
-                        </a:rPr>
-                        <a:t>19</a:t>
-                      </a:r>
-                      <a:endParaRPr lang="en-US" sz="1600" dirty="0">
-                        <a:latin typeface="Calibri" charset="0"/>
-                        <a:ea typeface="Calibri" charset="0"/>
-                        <a:cs typeface="Calibri" charset="0"/>
-                      </a:endParaRPr>
-                    </a:p>
-                  </a:txBody>
-                  <a:tcPr marL="64008" marR="64008" marT="36576" marB="36576" anchor="ctr">
-                    <a:lnL w="9525" cap="flat" cmpd="sng" algn="ctr">
-                      <a:solidFill>
-                        <a:srgbClr val="D8CDB8"/>
-                      </a:solidFill>
-                      <a:prstDash val="solid"/>
-                      <a:round/>
-                      <a:headEnd type="none" w="med" len="med"/>
-                      <a:tailEnd type="none" w="med" len="med"/>
-                    </a:lnL>
-                    <a:lnR w="9525" cap="flat" cmpd="sng" algn="ctr">
-                      <a:solidFill>
-                        <a:srgbClr val="D8CDB8"/>
-                      </a:solidFill>
-                      <a:prstDash val="solid"/>
-                      <a:round/>
-                      <a:headEnd type="none" w="med" len="med"/>
-                      <a:tailEnd type="none" w="med" len="med"/>
-                    </a:lnR>
-                    <a:lnT w="9525" cap="flat" cmpd="sng" algn="ctr">
-                      <a:solidFill>
-                        <a:srgbClr val="D8CDB8"/>
-                      </a:solidFill>
-                      <a:prstDash val="solid"/>
-                      <a:round/>
-                      <a:headEnd type="none" w="med" len="med"/>
-                      <a:tailEnd type="none" w="med" len="med"/>
-                    </a:lnT>
-                    <a:lnB w="9525" cap="flat" cmpd="sng" algn="ctr">
-                      <a:solidFill>
-                        <a:srgbClr val="D8CDB8"/>
-                      </a:solidFill>
-                      <a:prstDash val="solid"/>
-                      <a:round/>
-                      <a:headEnd type="none" w="med" len="med"/>
-                      <a:tailEnd type="none" w="med" len="med"/>
-                    </a:lnB>
-                    <a:solidFill>
-                      <a:srgbClr val="FFFFFF"/>
-                    </a:solidFill>
-                  </a:tcPr>
-                </a:tc>
-                <a:tc>
-                  <a:txBody>
-                    <a:bodyPr/>
-                    <a:lstStyle/>
-                    <a:p>
-                      <a:pPr algn="ctr" indent="0" marL="0">
-                        <a:buNone/>
-                      </a:pPr>
-                      <a:r>
-                        <a:rPr lang="en-US" sz="1600" dirty="0">
-                          <a:solidFill>
-                            <a:srgbClr val="1B1B1F"/>
-                          </a:solidFill>
-                          <a:latin typeface="Calibri" pitchFamily="34" charset="0"/>
-                          <a:ea typeface="Calibri" pitchFamily="34" charset="-122"/>
-                          <a:cs typeface="Calibri" pitchFamily="34" charset="-120"/>
-                        </a:rPr>
-                        <a:t>21</a:t>
-                      </a:r>
-                      <a:endParaRPr lang="en-US" sz="1600" dirty="0">
-                        <a:latin typeface="Calibri" charset="0"/>
-                        <a:ea typeface="Calibri" charset="0"/>
-                        <a:cs typeface="Calibri" charset="0"/>
-                      </a:endParaRPr>
-                    </a:p>
-                  </a:txBody>
-                  <a:tcPr marL="64008" marR="64008" marT="36576" marB="36576" anchor="ctr">
-                    <a:lnL w="9525" cap="flat" cmpd="sng" algn="ctr">
-                      <a:solidFill>
-                        <a:srgbClr val="D8CDB8"/>
-                      </a:solidFill>
-                      <a:prstDash val="solid"/>
-                      <a:round/>
-                      <a:headEnd type="none" w="med" len="med"/>
-                      <a:tailEnd type="none" w="med" len="med"/>
-                    </a:lnL>
-                    <a:lnR w="9525" cap="flat" cmpd="sng" algn="ctr">
-                      <a:solidFill>
-                        <a:srgbClr val="D8CDB8"/>
-                      </a:solidFill>
-                      <a:prstDash val="solid"/>
-                      <a:round/>
-                      <a:headEnd type="none" w="med" len="med"/>
-                      <a:tailEnd type="none" w="med" len="med"/>
-                    </a:lnR>
-                    <a:lnT w="9525" cap="flat" cmpd="sng" algn="ctr">
-                      <a:solidFill>
-                        <a:srgbClr val="D8CDB8"/>
-                      </a:solidFill>
-                      <a:prstDash val="solid"/>
-                      <a:round/>
-                      <a:headEnd type="none" w="med" len="med"/>
-                      <a:tailEnd type="none" w="med" len="med"/>
-                    </a:lnT>
-                    <a:lnB w="9525" cap="flat" cmpd="sng" algn="ctr">
-                      <a:solidFill>
-                        <a:srgbClr val="D8CDB8"/>
-                      </a:solidFill>
-                      <a:prstDash val="solid"/>
-                      <a:round/>
-                      <a:headEnd type="none" w="med" len="med"/>
-                      <a:tailEnd type="none" w="med" len="med"/>
-                    </a:lnB>
-                    <a:solidFill>
-                      <a:srgbClr val="FFFFFF"/>
-                    </a:solidFill>
-                  </a:tcPr>
-                </a:tc>
-                <a:tc>
-                  <a:txBody>
-                    <a:bodyPr/>
-                    <a:lstStyle/>
-                    <a:p>
-                      <a:pPr algn="ctr" indent="0" marL="0">
-                        <a:buNone/>
-                      </a:pPr>
-                      <a:r>
-                        <a:rPr lang="en-US" sz="1600" dirty="0">
-                          <a:solidFill>
-                            <a:srgbClr val="1B1B1F"/>
-                          </a:solidFill>
-                          <a:latin typeface="Calibri" pitchFamily="34" charset="0"/>
-                          <a:ea typeface="Calibri" pitchFamily="34" charset="-122"/>
-                          <a:cs typeface="Calibri" pitchFamily="34" charset="-120"/>
-                        </a:rPr>
-                        <a:t>23</a:t>
-                      </a:r>
-                      <a:endParaRPr lang="en-US" sz="1600" dirty="0">
-                        <a:latin typeface="Calibri" charset="0"/>
-                        <a:ea typeface="Calibri" charset="0"/>
-                        <a:cs typeface="Calibri" charset="0"/>
-                      </a:endParaRPr>
-                    </a:p>
-                  </a:txBody>
-                  <a:tcPr marL="64008" marR="64008" marT="36576" marB="36576" anchor="ctr">
-                    <a:lnL w="9525" cap="flat" cmpd="sng" algn="ctr">
-                      <a:solidFill>
-                        <a:srgbClr val="D8CDB8"/>
-                      </a:solidFill>
-                      <a:prstDash val="solid"/>
-                      <a:round/>
-                      <a:headEnd type="none" w="med" len="med"/>
-                      <a:tailEnd type="none" w="med" len="med"/>
-                    </a:lnL>
-                    <a:lnR w="9525" cap="flat" cmpd="sng" algn="ctr">
-                      <a:solidFill>
-                        <a:srgbClr val="D8CDB8"/>
-                      </a:solidFill>
-                      <a:prstDash val="solid"/>
-                      <a:round/>
-                      <a:headEnd type="none" w="med" len="med"/>
-                      <a:tailEnd type="none" w="med" len="med"/>
-                    </a:lnR>
-                    <a:lnT w="9525" cap="flat" cmpd="sng" algn="ctr">
-                      <a:solidFill>
-                        <a:srgbClr val="D8CDB8"/>
-                      </a:solidFill>
-                      <a:prstDash val="solid"/>
-                      <a:round/>
-                      <a:headEnd type="none" w="med" len="med"/>
-                      <a:tailEnd type="none" w="med" len="med"/>
-                    </a:lnT>
-                    <a:lnB w="9525" cap="flat" cmpd="sng" algn="ctr">
-                      <a:solidFill>
-                        <a:srgbClr val="D8CDB8"/>
-                      </a:solidFill>
-                      <a:prstDash val="solid"/>
-                      <a:round/>
-                      <a:headEnd type="none" w="med" len="med"/>
-                      <a:tailEnd type="none" w="med" len="med"/>
-                    </a:lnB>
-                    <a:solidFill>
-                      <a:srgbClr val="FFFFFF"/>
-                    </a:solidFill>
-                  </a:tcPr>
-                </a:tc>
-                <a:tc>
-                  <a:txBody>
-                    <a:bodyPr/>
-                    <a:lstStyle/>
-                    <a:p>
-                      <a:pPr algn="ctr" indent="0" marL="0">
-                        <a:buNone/>
-                      </a:pPr>
-                      <a:r>
-                        <a:rPr lang="en-US" sz="1600" dirty="0">
-                          <a:solidFill>
-                            <a:srgbClr val="1B1B1F"/>
-                          </a:solidFill>
-                          <a:latin typeface="Calibri" pitchFamily="34" charset="0"/>
-                          <a:ea typeface="Calibri" pitchFamily="34" charset="-122"/>
-                          <a:cs typeface="Calibri" pitchFamily="34" charset="-120"/>
-                        </a:rPr>
-                        <a:t>25</a:t>
-                      </a:r>
-                      <a:endParaRPr lang="en-US" sz="1600" dirty="0">
-                        <a:latin typeface="Calibri" charset="0"/>
-                        <a:ea typeface="Calibri" charset="0"/>
-                        <a:cs typeface="Calibri" charset="0"/>
-                      </a:endParaRPr>
-                    </a:p>
-                  </a:txBody>
-                  <a:tcPr marL="64008" marR="64008" marT="36576" marB="36576" anchor="ctr">
-                    <a:lnL w="9525" cap="flat" cmpd="sng" algn="ctr">
-                      <a:solidFill>
-                        <a:srgbClr val="D8CDB8"/>
-                      </a:solidFill>
-                      <a:prstDash val="solid"/>
-                      <a:round/>
-                      <a:headEnd type="none" w="med" len="med"/>
-                      <a:tailEnd type="none" w="med" len="med"/>
-                    </a:lnL>
-                    <a:lnR w="9525" cap="flat" cmpd="sng" algn="ctr">
-                      <a:solidFill>
-                        <a:srgbClr val="D8CDB8"/>
-                      </a:solidFill>
-                      <a:prstDash val="solid"/>
-                      <a:round/>
-                      <a:headEnd type="none" w="med" len="med"/>
-                      <a:tailEnd type="none" w="med" len="med"/>
-                    </a:lnR>
-                    <a:lnT w="9525" cap="flat" cmpd="sng" algn="ctr">
-                      <a:solidFill>
-                        <a:srgbClr val="D8CDB8"/>
-                      </a:solidFill>
-                      <a:prstDash val="solid"/>
-                      <a:round/>
-                      <a:headEnd type="none" w="med" len="med"/>
-                      <a:tailEnd type="none" w="med" len="med"/>
-                    </a:lnT>
-                    <a:lnB w="9525" cap="flat" cmpd="sng" algn="ctr">
-                      <a:solidFill>
-                        <a:srgbClr val="D8CDB8"/>
-                      </a:solidFill>
-                      <a:prstDash val="solid"/>
-                      <a:round/>
-                      <a:headEnd type="none" w="med" len="med"/>
-                      <a:tailEnd type="none" w="med" len="med"/>
-                    </a:lnB>
-                    <a:solidFill>
-                      <a:srgbClr val="FFFFFF"/>
-                    </a:solidFill>
-                  </a:tcPr>
-                </a:tc>
-              </a:tr>
-              <a:tr h="0">
-                <a:tc>
-                  <a:txBody>
-                    <a:bodyPr/>
-                    <a:lstStyle/>
-                    <a:p>
-                      <a:pPr algn="ctr" indent="0" marL="0">
-                        <a:buNone/>
-                      </a:pPr>
-                      <a:r>
-                        <a:rPr lang="en-US" sz="1600" b="1" dirty="0">
-                          <a:solidFill>
-                            <a:srgbClr val="1B1B1F"/>
-                          </a:solidFill>
-                          <a:latin typeface="Calibri" pitchFamily="34" charset="0"/>
-                          <a:ea typeface="Calibri" pitchFamily="34" charset="-122"/>
-                          <a:cs typeface="Calibri" pitchFamily="34" charset="-120"/>
-                        </a:rPr>
-                        <a:t>m</a:t>
-                      </a:r>
-                      <a:r>
-                        <a:rPr lang="en-US" sz="1600" b="1" baseline="30000" dirty="0">
-                          <a:solidFill>
-                            <a:srgbClr val="1B1B1F"/>
-                          </a:solidFill>
-                          <a:latin typeface="Calibri" pitchFamily="34" charset="0"/>
-                          <a:ea typeface="Calibri" pitchFamily="34" charset="-122"/>
-                          <a:cs typeface="Calibri" pitchFamily="34" charset="-120"/>
-                        </a:rPr>
-                        <a:t>−1</a:t>
-                      </a:r>
-                      <a:endParaRPr lang="en-US" sz="1600" dirty="0">
-                        <a:latin typeface="Calibri" charset="0"/>
-                        <a:ea typeface="Calibri" charset="0"/>
-                        <a:cs typeface="Calibri" charset="0"/>
-                      </a:endParaRPr>
-                    </a:p>
-                  </a:txBody>
-                  <a:tcPr marL="64008" marR="64008" marT="36576" marB="36576" anchor="ctr">
-                    <a:lnL w="9525" cap="flat" cmpd="sng" algn="ctr">
-                      <a:solidFill>
-                        <a:srgbClr val="D8CDB8"/>
-                      </a:solidFill>
-                      <a:prstDash val="solid"/>
-                      <a:round/>
-                      <a:headEnd type="none" w="med" len="med"/>
-                      <a:tailEnd type="none" w="med" len="med"/>
-                    </a:lnL>
-                    <a:lnR w="9525" cap="flat" cmpd="sng" algn="ctr">
-                      <a:solidFill>
-                        <a:srgbClr val="D8CDB8"/>
-                      </a:solidFill>
-                      <a:prstDash val="solid"/>
-                      <a:round/>
-                      <a:headEnd type="none" w="med" len="med"/>
-                      <a:tailEnd type="none" w="med" len="med"/>
-                    </a:lnR>
-                    <a:lnT w="9525" cap="flat" cmpd="sng" algn="ctr">
-                      <a:solidFill>
-                        <a:srgbClr val="D8CDB8"/>
-                      </a:solidFill>
-                      <a:prstDash val="solid"/>
-                      <a:round/>
-                      <a:headEnd type="none" w="med" len="med"/>
-                      <a:tailEnd type="none" w="med" len="med"/>
-                    </a:lnT>
-                    <a:lnB w="9525" cap="flat" cmpd="sng" algn="ctr">
-                      <a:solidFill>
-                        <a:srgbClr val="D8CDB8"/>
-                      </a:solidFill>
-                      <a:prstDash val="solid"/>
-                      <a:round/>
-                      <a:headEnd type="none" w="med" len="med"/>
-                      <a:tailEnd type="none" w="med" len="med"/>
-                    </a:lnB>
-                    <a:solidFill>
-                      <a:srgbClr val="F2EADB"/>
-                    </a:solidFill>
-                  </a:tcPr>
-                </a:tc>
-                <a:tc>
-                  <a:txBody>
-                    <a:bodyPr/>
-                    <a:lstStyle/>
-                    <a:p>
-                      <a:pPr algn="ctr" indent="0" marL="0">
-                        <a:buNone/>
-                      </a:pPr>
-                      <a:r>
-                        <a:rPr lang="en-US" sz="1600" dirty="0">
-                          <a:solidFill>
-                            <a:srgbClr val="1B1B1F"/>
-                          </a:solidFill>
-                          <a:latin typeface="Calibri" pitchFamily="34" charset="0"/>
-                          <a:ea typeface="Calibri" pitchFamily="34" charset="-122"/>
-                          <a:cs typeface="Calibri" pitchFamily="34" charset="-120"/>
-                        </a:rPr>
-                        <a:t>1</a:t>
-                      </a:r>
-                      <a:endParaRPr lang="en-US" sz="1600" dirty="0">
-                        <a:latin typeface="Calibri" charset="0"/>
-                        <a:ea typeface="Calibri" charset="0"/>
-                        <a:cs typeface="Calibri" charset="0"/>
-                      </a:endParaRPr>
-                    </a:p>
-                  </a:txBody>
-                  <a:tcPr marL="64008" marR="64008" marT="36576" marB="36576" anchor="ctr">
-                    <a:lnL w="9525" cap="flat" cmpd="sng" algn="ctr">
-                      <a:solidFill>
-                        <a:srgbClr val="D8CDB8"/>
-                      </a:solidFill>
-                      <a:prstDash val="solid"/>
-                      <a:round/>
-                      <a:headEnd type="none" w="med" len="med"/>
-                      <a:tailEnd type="none" w="med" len="med"/>
-                    </a:lnL>
-                    <a:lnR w="9525" cap="flat" cmpd="sng" algn="ctr">
-                      <a:solidFill>
-                        <a:srgbClr val="D8CDB8"/>
-                      </a:solidFill>
-                      <a:prstDash val="solid"/>
-                      <a:round/>
-                      <a:headEnd type="none" w="med" len="med"/>
-                      <a:tailEnd type="none" w="med" len="med"/>
-                    </a:lnR>
-                    <a:lnT w="9525" cap="flat" cmpd="sng" algn="ctr">
-                      <a:solidFill>
-                        <a:srgbClr val="D8CDB8"/>
-                      </a:solidFill>
-                      <a:prstDash val="solid"/>
-                      <a:round/>
-                      <a:headEnd type="none" w="med" len="med"/>
-                      <a:tailEnd type="none" w="med" len="med"/>
-                    </a:lnT>
-                    <a:lnB w="9525" cap="flat" cmpd="sng" algn="ctr">
-                      <a:solidFill>
-                        <a:srgbClr val="D8CDB8"/>
-                      </a:solidFill>
-                      <a:prstDash val="solid"/>
-                      <a:round/>
-                      <a:headEnd type="none" w="med" len="med"/>
-                      <a:tailEnd type="none" w="med" len="med"/>
-                    </a:lnB>
-                    <a:solidFill>
-                      <a:srgbClr val="FFFFFF"/>
-                    </a:solidFill>
-                  </a:tcPr>
-                </a:tc>
-                <a:tc>
-                  <a:txBody>
-                    <a:bodyPr/>
-                    <a:lstStyle/>
-                    <a:p>
-                      <a:pPr algn="ctr" indent="0" marL="0">
-                        <a:buNone/>
-                      </a:pPr>
-                      <a:r>
-                        <a:rPr lang="en-US" sz="1600" dirty="0">
-                          <a:solidFill>
-                            <a:srgbClr val="1B1B1F"/>
-                          </a:solidFill>
-                          <a:latin typeface="Calibri" pitchFamily="34" charset="0"/>
-                          <a:ea typeface="Calibri" pitchFamily="34" charset="-122"/>
-                          <a:cs typeface="Calibri" pitchFamily="34" charset="-120"/>
-                        </a:rPr>
-                        <a:t>9</a:t>
-                      </a:r>
-                      <a:endParaRPr lang="en-US" sz="1600" dirty="0">
-                        <a:latin typeface="Calibri" charset="0"/>
-                        <a:ea typeface="Calibri" charset="0"/>
-                        <a:cs typeface="Calibri" charset="0"/>
-                      </a:endParaRPr>
-                    </a:p>
-                  </a:txBody>
-                  <a:tcPr marL="64008" marR="64008" marT="36576" marB="36576" anchor="ctr">
-                    <a:lnL w="9525" cap="flat" cmpd="sng" algn="ctr">
-                      <a:solidFill>
-                        <a:srgbClr val="D8CDB8"/>
-                      </a:solidFill>
-                      <a:prstDash val="solid"/>
-                      <a:round/>
-                      <a:headEnd type="none" w="med" len="med"/>
-                      <a:tailEnd type="none" w="med" len="med"/>
-                    </a:lnL>
-                    <a:lnR w="9525" cap="flat" cmpd="sng" algn="ctr">
-                      <a:solidFill>
-                        <a:srgbClr val="D8CDB8"/>
-                      </a:solidFill>
-                      <a:prstDash val="solid"/>
-                      <a:round/>
-                      <a:headEnd type="none" w="med" len="med"/>
-                      <a:tailEnd type="none" w="med" len="med"/>
-                    </a:lnR>
-                    <a:lnT w="9525" cap="flat" cmpd="sng" algn="ctr">
-                      <a:solidFill>
-                        <a:srgbClr val="D8CDB8"/>
-                      </a:solidFill>
-                      <a:prstDash val="solid"/>
-                      <a:round/>
-                      <a:headEnd type="none" w="med" len="med"/>
-                      <a:tailEnd type="none" w="med" len="med"/>
-                    </a:lnT>
-                    <a:lnB w="9525" cap="flat" cmpd="sng" algn="ctr">
-                      <a:solidFill>
-                        <a:srgbClr val="D8CDB8"/>
-                      </a:solidFill>
-                      <a:prstDash val="solid"/>
-                      <a:round/>
-                      <a:headEnd type="none" w="med" len="med"/>
-                      <a:tailEnd type="none" w="med" len="med"/>
-                    </a:lnB>
-                    <a:solidFill>
-                      <a:srgbClr val="FFFFFF"/>
-                    </a:solidFill>
-                  </a:tcPr>
-                </a:tc>
-                <a:tc>
-                  <a:txBody>
-                    <a:bodyPr/>
-                    <a:lstStyle/>
-                    <a:p>
-                      <a:pPr algn="ctr" indent="0" marL="0">
-                        <a:buNone/>
-                      </a:pPr>
-                      <a:r>
-                        <a:rPr lang="en-US" sz="1600" dirty="0">
-                          <a:solidFill>
-                            <a:srgbClr val="1B1B1F"/>
-                          </a:solidFill>
-                          <a:latin typeface="Calibri" pitchFamily="34" charset="0"/>
-                          <a:ea typeface="Calibri" pitchFamily="34" charset="-122"/>
-                          <a:cs typeface="Calibri" pitchFamily="34" charset="-120"/>
-                        </a:rPr>
-                        <a:t>21</a:t>
-                      </a:r>
-                      <a:endParaRPr lang="en-US" sz="1600" dirty="0">
-                        <a:latin typeface="Calibri" charset="0"/>
-                        <a:ea typeface="Calibri" charset="0"/>
-                        <a:cs typeface="Calibri" charset="0"/>
-                      </a:endParaRPr>
-                    </a:p>
-                  </a:txBody>
-                  <a:tcPr marL="64008" marR="64008" marT="36576" marB="36576" anchor="ctr">
-                    <a:lnL w="9525" cap="flat" cmpd="sng" algn="ctr">
-                      <a:solidFill>
-                        <a:srgbClr val="D8CDB8"/>
-                      </a:solidFill>
-                      <a:prstDash val="solid"/>
-                      <a:round/>
-                      <a:headEnd type="none" w="med" len="med"/>
-                      <a:tailEnd type="none" w="med" len="med"/>
-                    </a:lnL>
-                    <a:lnR w="9525" cap="flat" cmpd="sng" algn="ctr">
-                      <a:solidFill>
-                        <a:srgbClr val="D8CDB8"/>
-                      </a:solidFill>
-                      <a:prstDash val="solid"/>
-                      <a:round/>
-                      <a:headEnd type="none" w="med" len="med"/>
-                      <a:tailEnd type="none" w="med" len="med"/>
-                    </a:lnR>
-                    <a:lnT w="9525" cap="flat" cmpd="sng" algn="ctr">
-                      <a:solidFill>
-                        <a:srgbClr val="D8CDB8"/>
-                      </a:solidFill>
-                      <a:prstDash val="solid"/>
-                      <a:round/>
-                      <a:headEnd type="none" w="med" len="med"/>
-                      <a:tailEnd type="none" w="med" len="med"/>
-                    </a:lnT>
-                    <a:lnB w="9525" cap="flat" cmpd="sng" algn="ctr">
-                      <a:solidFill>
-                        <a:srgbClr val="D8CDB8"/>
-                      </a:solidFill>
-                      <a:prstDash val="solid"/>
-                      <a:round/>
-                      <a:headEnd type="none" w="med" len="med"/>
-                      <a:tailEnd type="none" w="med" len="med"/>
-                    </a:lnB>
-                    <a:solidFill>
-                      <a:srgbClr val="FFFFFF"/>
-                    </a:solidFill>
-                  </a:tcPr>
-                </a:tc>
-                <a:tc>
-                  <a:txBody>
-                    <a:bodyPr/>
-                    <a:lstStyle/>
-                    <a:p>
-                      <a:pPr algn="ctr" indent="0" marL="0">
-                        <a:buNone/>
-                      </a:pPr>
-                      <a:r>
-                        <a:rPr lang="en-US" sz="1600" dirty="0">
-                          <a:solidFill>
-                            <a:srgbClr val="1B1B1F"/>
-                          </a:solidFill>
-                          <a:latin typeface="Calibri" pitchFamily="34" charset="0"/>
-                          <a:ea typeface="Calibri" pitchFamily="34" charset="-122"/>
-                          <a:cs typeface="Calibri" pitchFamily="34" charset="-120"/>
-                        </a:rPr>
-                        <a:t>15</a:t>
-                      </a:r>
-                      <a:endParaRPr lang="en-US" sz="1600" dirty="0">
-                        <a:latin typeface="Calibri" charset="0"/>
-                        <a:ea typeface="Calibri" charset="0"/>
-                        <a:cs typeface="Calibri" charset="0"/>
-                      </a:endParaRPr>
-                    </a:p>
-                  </a:txBody>
-                  <a:tcPr marL="64008" marR="64008" marT="36576" marB="36576" anchor="ctr">
-                    <a:lnL w="9525" cap="flat" cmpd="sng" algn="ctr">
-                      <a:solidFill>
-                        <a:srgbClr val="D8CDB8"/>
-                      </a:solidFill>
-                      <a:prstDash val="solid"/>
-                      <a:round/>
-                      <a:headEnd type="none" w="med" len="med"/>
-                      <a:tailEnd type="none" w="med" len="med"/>
-                    </a:lnL>
-                    <a:lnR w="9525" cap="flat" cmpd="sng" algn="ctr">
-                      <a:solidFill>
-                        <a:srgbClr val="D8CDB8"/>
-                      </a:solidFill>
-                      <a:prstDash val="solid"/>
-                      <a:round/>
-                      <a:headEnd type="none" w="med" len="med"/>
-                      <a:tailEnd type="none" w="med" len="med"/>
-                    </a:lnR>
-                    <a:lnT w="9525" cap="flat" cmpd="sng" algn="ctr">
-                      <a:solidFill>
-                        <a:srgbClr val="D8CDB8"/>
-                      </a:solidFill>
-                      <a:prstDash val="solid"/>
-                      <a:round/>
-                      <a:headEnd type="none" w="med" len="med"/>
-                      <a:tailEnd type="none" w="med" len="med"/>
-                    </a:lnT>
-                    <a:lnB w="9525" cap="flat" cmpd="sng" algn="ctr">
-                      <a:solidFill>
-                        <a:srgbClr val="D8CDB8"/>
-                      </a:solidFill>
-                      <a:prstDash val="solid"/>
-                      <a:round/>
-                      <a:headEnd type="none" w="med" len="med"/>
-                      <a:tailEnd type="none" w="med" len="med"/>
-                    </a:lnB>
-                    <a:solidFill>
-                      <a:srgbClr val="FFFFFF"/>
-                    </a:solidFill>
-                  </a:tcPr>
-                </a:tc>
-                <a:tc>
-                  <a:txBody>
-                    <a:bodyPr/>
-                    <a:lstStyle/>
-                    <a:p>
-                      <a:pPr algn="ctr" indent="0" marL="0">
-                        <a:buNone/>
-                      </a:pPr>
-                      <a:r>
-                        <a:rPr lang="en-US" sz="1600" dirty="0">
-                          <a:solidFill>
-                            <a:srgbClr val="1B1B1F"/>
-                          </a:solidFill>
-                          <a:latin typeface="Calibri" pitchFamily="34" charset="0"/>
-                          <a:ea typeface="Calibri" pitchFamily="34" charset="-122"/>
-                          <a:cs typeface="Calibri" pitchFamily="34" charset="-120"/>
-                        </a:rPr>
-                        <a:t>3</a:t>
-                      </a:r>
-                      <a:endParaRPr lang="en-US" sz="1600" dirty="0">
-                        <a:latin typeface="Calibri" charset="0"/>
-                        <a:ea typeface="Calibri" charset="0"/>
-                        <a:cs typeface="Calibri" charset="0"/>
-                      </a:endParaRPr>
-                    </a:p>
-                  </a:txBody>
-                  <a:tcPr marL="64008" marR="64008" marT="36576" marB="36576" anchor="ctr">
-                    <a:lnL w="9525" cap="flat" cmpd="sng" algn="ctr">
-                      <a:solidFill>
-                        <a:srgbClr val="D8CDB8"/>
-                      </a:solidFill>
-                      <a:prstDash val="solid"/>
-                      <a:round/>
-                      <a:headEnd type="none" w="med" len="med"/>
-                      <a:tailEnd type="none" w="med" len="med"/>
-                    </a:lnL>
-                    <a:lnR w="9525" cap="flat" cmpd="sng" algn="ctr">
-                      <a:solidFill>
-                        <a:srgbClr val="D8CDB8"/>
-                      </a:solidFill>
-                      <a:prstDash val="solid"/>
-                      <a:round/>
-                      <a:headEnd type="none" w="med" len="med"/>
-                      <a:tailEnd type="none" w="med" len="med"/>
-                    </a:lnR>
-                    <a:lnT w="9525" cap="flat" cmpd="sng" algn="ctr">
-                      <a:solidFill>
-                        <a:srgbClr val="D8CDB8"/>
-                      </a:solidFill>
-                      <a:prstDash val="solid"/>
-                      <a:round/>
-                      <a:headEnd type="none" w="med" len="med"/>
-                      <a:tailEnd type="none" w="med" len="med"/>
-                    </a:lnT>
-                    <a:lnB w="9525" cap="flat" cmpd="sng" algn="ctr">
-                      <a:solidFill>
-                        <a:srgbClr val="D8CDB8"/>
-                      </a:solidFill>
-                      <a:prstDash val="solid"/>
-                      <a:round/>
-                      <a:headEnd type="none" w="med" len="med"/>
-                      <a:tailEnd type="none" w="med" len="med"/>
-                    </a:lnB>
-                    <a:solidFill>
-                      <a:srgbClr val="FFFFFF"/>
-                    </a:solidFill>
-                  </a:tcPr>
-                </a:tc>
-                <a:tc>
-                  <a:txBody>
-                    <a:bodyPr/>
-                    <a:lstStyle/>
-                    <a:p>
-                      <a:pPr algn="ctr" indent="0" marL="0">
-                        <a:buNone/>
-                      </a:pPr>
-                      <a:r>
-                        <a:rPr lang="en-US" sz="1600" dirty="0">
-                          <a:solidFill>
-                            <a:srgbClr val="1B1B1F"/>
-                          </a:solidFill>
-                          <a:latin typeface="Calibri" pitchFamily="34" charset="0"/>
-                          <a:ea typeface="Calibri" pitchFamily="34" charset="-122"/>
-                          <a:cs typeface="Calibri" pitchFamily="34" charset="-120"/>
-                        </a:rPr>
-                        <a:t>19</a:t>
-                      </a:r>
-                      <a:endParaRPr lang="en-US" sz="1600" dirty="0">
-                        <a:latin typeface="Calibri" charset="0"/>
-                        <a:ea typeface="Calibri" charset="0"/>
-                        <a:cs typeface="Calibri" charset="0"/>
-                      </a:endParaRPr>
-                    </a:p>
-                  </a:txBody>
-                  <a:tcPr marL="64008" marR="64008" marT="36576" marB="36576" anchor="ctr">
-                    <a:lnL w="9525" cap="flat" cmpd="sng" algn="ctr">
-                      <a:solidFill>
-                        <a:srgbClr val="D8CDB8"/>
-                      </a:solidFill>
-                      <a:prstDash val="solid"/>
-                      <a:round/>
-                      <a:headEnd type="none" w="med" len="med"/>
-                      <a:tailEnd type="none" w="med" len="med"/>
-                    </a:lnL>
-                    <a:lnR w="9525" cap="flat" cmpd="sng" algn="ctr">
-                      <a:solidFill>
-                        <a:srgbClr val="D8CDB8"/>
-                      </a:solidFill>
-                      <a:prstDash val="solid"/>
-                      <a:round/>
-                      <a:headEnd type="none" w="med" len="med"/>
-                      <a:tailEnd type="none" w="med" len="med"/>
-                    </a:lnR>
-                    <a:lnT w="9525" cap="flat" cmpd="sng" algn="ctr">
-                      <a:solidFill>
-                        <a:srgbClr val="D8CDB8"/>
-                      </a:solidFill>
-                      <a:prstDash val="solid"/>
-                      <a:round/>
-                      <a:headEnd type="none" w="med" len="med"/>
-                      <a:tailEnd type="none" w="med" len="med"/>
-                    </a:lnT>
-                    <a:lnB w="9525" cap="flat" cmpd="sng" algn="ctr">
-                      <a:solidFill>
-                        <a:srgbClr val="D8CDB8"/>
-                      </a:solidFill>
-                      <a:prstDash val="solid"/>
-                      <a:round/>
-                      <a:headEnd type="none" w="med" len="med"/>
-                      <a:tailEnd type="none" w="med" len="med"/>
-                    </a:lnB>
-                    <a:solidFill>
-                      <a:srgbClr val="FFFFFF"/>
-                    </a:solidFill>
-                  </a:tcPr>
-                </a:tc>
-                <a:tc>
-                  <a:txBody>
-                    <a:bodyPr/>
-                    <a:lstStyle/>
-                    <a:p>
-                      <a:pPr algn="ctr" indent="0" marL="0">
-                        <a:buNone/>
-                      </a:pPr>
-                      <a:r>
-                        <a:rPr lang="en-US" sz="1600" dirty="0">
-                          <a:solidFill>
-                            <a:srgbClr val="1B1B1F"/>
-                          </a:solidFill>
-                          <a:latin typeface="Calibri" pitchFamily="34" charset="0"/>
-                          <a:ea typeface="Calibri" pitchFamily="34" charset="-122"/>
-                          <a:cs typeface="Calibri" pitchFamily="34" charset="-120"/>
-                        </a:rPr>
-                        <a:t>7</a:t>
-                      </a:r>
-                      <a:endParaRPr lang="en-US" sz="1600" dirty="0">
-                        <a:latin typeface="Calibri" charset="0"/>
-                        <a:ea typeface="Calibri" charset="0"/>
-                        <a:cs typeface="Calibri" charset="0"/>
-                      </a:endParaRPr>
-                    </a:p>
-                  </a:txBody>
-                  <a:tcPr marL="64008" marR="64008" marT="36576" marB="36576" anchor="ctr">
-                    <a:lnL w="9525" cap="flat" cmpd="sng" algn="ctr">
-                      <a:solidFill>
-                        <a:srgbClr val="D8CDB8"/>
-                      </a:solidFill>
-                      <a:prstDash val="solid"/>
-                      <a:round/>
-                      <a:headEnd type="none" w="med" len="med"/>
-                      <a:tailEnd type="none" w="med" len="med"/>
-                    </a:lnL>
-                    <a:lnR w="9525" cap="flat" cmpd="sng" algn="ctr">
-                      <a:solidFill>
-                        <a:srgbClr val="D8CDB8"/>
-                      </a:solidFill>
-                      <a:prstDash val="solid"/>
-                      <a:round/>
-                      <a:headEnd type="none" w="med" len="med"/>
-                      <a:tailEnd type="none" w="med" len="med"/>
-                    </a:lnR>
-                    <a:lnT w="9525" cap="flat" cmpd="sng" algn="ctr">
-                      <a:solidFill>
-                        <a:srgbClr val="D8CDB8"/>
-                      </a:solidFill>
-                      <a:prstDash val="solid"/>
-                      <a:round/>
-                      <a:headEnd type="none" w="med" len="med"/>
-                      <a:tailEnd type="none" w="med" len="med"/>
-                    </a:lnT>
-                    <a:lnB w="9525" cap="flat" cmpd="sng" algn="ctr">
-                      <a:solidFill>
-                        <a:srgbClr val="D8CDB8"/>
-                      </a:solidFill>
-                      <a:prstDash val="solid"/>
-                      <a:round/>
-                      <a:headEnd type="none" w="med" len="med"/>
-                      <a:tailEnd type="none" w="med" len="med"/>
-                    </a:lnB>
-                    <a:solidFill>
-                      <a:srgbClr val="FFFFFF"/>
-                    </a:solidFill>
-                  </a:tcPr>
-                </a:tc>
-                <a:tc>
-                  <a:txBody>
-                    <a:bodyPr/>
-                    <a:lstStyle/>
-                    <a:p>
-                      <a:pPr algn="ctr" indent="0" marL="0">
-                        <a:buNone/>
-                      </a:pPr>
-                      <a:r>
-                        <a:rPr lang="en-US" sz="1600" dirty="0">
-                          <a:solidFill>
-                            <a:srgbClr val="1B1B1F"/>
-                          </a:solidFill>
-                          <a:latin typeface="Calibri" pitchFamily="34" charset="0"/>
-                          <a:ea typeface="Calibri" pitchFamily="34" charset="-122"/>
-                          <a:cs typeface="Calibri" pitchFamily="34" charset="-120"/>
-                        </a:rPr>
-                        <a:t>23</a:t>
-                      </a:r>
-                      <a:endParaRPr lang="en-US" sz="1600" dirty="0">
-                        <a:latin typeface="Calibri" charset="0"/>
-                        <a:ea typeface="Calibri" charset="0"/>
-                        <a:cs typeface="Calibri" charset="0"/>
-                      </a:endParaRPr>
-                    </a:p>
-                  </a:txBody>
-                  <a:tcPr marL="64008" marR="64008" marT="36576" marB="36576" anchor="ctr">
-                    <a:lnL w="9525" cap="flat" cmpd="sng" algn="ctr">
-                      <a:solidFill>
-                        <a:srgbClr val="D8CDB8"/>
-                      </a:solidFill>
-                      <a:prstDash val="solid"/>
-                      <a:round/>
-                      <a:headEnd type="none" w="med" len="med"/>
-                      <a:tailEnd type="none" w="med" len="med"/>
-                    </a:lnL>
-                    <a:lnR w="9525" cap="flat" cmpd="sng" algn="ctr">
-                      <a:solidFill>
-                        <a:srgbClr val="D8CDB8"/>
-                      </a:solidFill>
-                      <a:prstDash val="solid"/>
-                      <a:round/>
-                      <a:headEnd type="none" w="med" len="med"/>
-                      <a:tailEnd type="none" w="med" len="med"/>
-                    </a:lnR>
-                    <a:lnT w="9525" cap="flat" cmpd="sng" algn="ctr">
-                      <a:solidFill>
-                        <a:srgbClr val="D8CDB8"/>
-                      </a:solidFill>
-                      <a:prstDash val="solid"/>
-                      <a:round/>
-                      <a:headEnd type="none" w="med" len="med"/>
-                      <a:tailEnd type="none" w="med" len="med"/>
-                    </a:lnT>
-                    <a:lnB w="9525" cap="flat" cmpd="sng" algn="ctr">
-                      <a:solidFill>
-                        <a:srgbClr val="D8CDB8"/>
-                      </a:solidFill>
-                      <a:prstDash val="solid"/>
-                      <a:round/>
-                      <a:headEnd type="none" w="med" len="med"/>
-                      <a:tailEnd type="none" w="med" len="med"/>
-                    </a:lnB>
-                    <a:solidFill>
-                      <a:srgbClr val="FFFFFF"/>
-                    </a:solidFill>
-                  </a:tcPr>
-                </a:tc>
-                <a:tc>
-                  <a:txBody>
-                    <a:bodyPr/>
-                    <a:lstStyle/>
-                    <a:p>
-                      <a:pPr algn="ctr" indent="0" marL="0">
-                        <a:buNone/>
-                      </a:pPr>
-                      <a:r>
-                        <a:rPr lang="en-US" sz="1600" dirty="0">
-                          <a:solidFill>
-                            <a:srgbClr val="1B1B1F"/>
-                          </a:solidFill>
-                          <a:latin typeface="Calibri" pitchFamily="34" charset="0"/>
-                          <a:ea typeface="Calibri" pitchFamily="34" charset="-122"/>
-                          <a:cs typeface="Calibri" pitchFamily="34" charset="-120"/>
-                        </a:rPr>
-                        <a:t>11</a:t>
-                      </a:r>
-                      <a:endParaRPr lang="en-US" sz="1600" dirty="0">
-                        <a:latin typeface="Calibri" charset="0"/>
-                        <a:ea typeface="Calibri" charset="0"/>
-                        <a:cs typeface="Calibri" charset="0"/>
-                      </a:endParaRPr>
-                    </a:p>
-                  </a:txBody>
-                  <a:tcPr marL="64008" marR="64008" marT="36576" marB="36576" anchor="ctr">
-                    <a:lnL w="9525" cap="flat" cmpd="sng" algn="ctr">
-                      <a:solidFill>
-                        <a:srgbClr val="D8CDB8"/>
-                      </a:solidFill>
-                      <a:prstDash val="solid"/>
-                      <a:round/>
-                      <a:headEnd type="none" w="med" len="med"/>
-                      <a:tailEnd type="none" w="med" len="med"/>
-                    </a:lnL>
-                    <a:lnR w="9525" cap="flat" cmpd="sng" algn="ctr">
-                      <a:solidFill>
-                        <a:srgbClr val="D8CDB8"/>
-                      </a:solidFill>
-                      <a:prstDash val="solid"/>
-                      <a:round/>
-                      <a:headEnd type="none" w="med" len="med"/>
-                      <a:tailEnd type="none" w="med" len="med"/>
-                    </a:lnR>
-                    <a:lnT w="9525" cap="flat" cmpd="sng" algn="ctr">
-                      <a:solidFill>
-                        <a:srgbClr val="D8CDB8"/>
-                      </a:solidFill>
-                      <a:prstDash val="solid"/>
-                      <a:round/>
-                      <a:headEnd type="none" w="med" len="med"/>
-                      <a:tailEnd type="none" w="med" len="med"/>
-                    </a:lnT>
-                    <a:lnB w="9525" cap="flat" cmpd="sng" algn="ctr">
-                      <a:solidFill>
-                        <a:srgbClr val="D8CDB8"/>
-                      </a:solidFill>
-                      <a:prstDash val="solid"/>
-                      <a:round/>
-                      <a:headEnd type="none" w="med" len="med"/>
-                      <a:tailEnd type="none" w="med" len="med"/>
-                    </a:lnB>
-                    <a:solidFill>
-                      <a:srgbClr val="FFFFFF"/>
-                    </a:solidFill>
-                  </a:tcPr>
-                </a:tc>
-                <a:tc>
-                  <a:txBody>
-                    <a:bodyPr/>
-                    <a:lstStyle/>
-                    <a:p>
-                      <a:pPr algn="ctr" indent="0" marL="0">
-                        <a:buNone/>
-                      </a:pPr>
-                      <a:r>
-                        <a:rPr lang="en-US" sz="1600" dirty="0">
-                          <a:solidFill>
-                            <a:srgbClr val="1B1B1F"/>
-                          </a:solidFill>
-                          <a:latin typeface="Calibri" pitchFamily="34" charset="0"/>
-                          <a:ea typeface="Calibri" pitchFamily="34" charset="-122"/>
-                          <a:cs typeface="Calibri" pitchFamily="34" charset="-120"/>
-                        </a:rPr>
-                        <a:t>5</a:t>
-                      </a:r>
-                      <a:endParaRPr lang="en-US" sz="1600" dirty="0">
-                        <a:latin typeface="Calibri" charset="0"/>
-                        <a:ea typeface="Calibri" charset="0"/>
-                        <a:cs typeface="Calibri" charset="0"/>
-                      </a:endParaRPr>
-                    </a:p>
-                  </a:txBody>
-                  <a:tcPr marL="64008" marR="64008" marT="36576" marB="36576" anchor="ctr">
-                    <a:lnL w="9525" cap="flat" cmpd="sng" algn="ctr">
-                      <a:solidFill>
-                        <a:srgbClr val="D8CDB8"/>
-                      </a:solidFill>
-                      <a:prstDash val="solid"/>
-                      <a:round/>
-                      <a:headEnd type="none" w="med" len="med"/>
-                      <a:tailEnd type="none" w="med" len="med"/>
-                    </a:lnL>
-                    <a:lnR w="9525" cap="flat" cmpd="sng" algn="ctr">
-                      <a:solidFill>
-                        <a:srgbClr val="D8CDB8"/>
-                      </a:solidFill>
-                      <a:prstDash val="solid"/>
-                      <a:round/>
-                      <a:headEnd type="none" w="med" len="med"/>
-                      <a:tailEnd type="none" w="med" len="med"/>
-                    </a:lnR>
-                    <a:lnT w="9525" cap="flat" cmpd="sng" algn="ctr">
-                      <a:solidFill>
-                        <a:srgbClr val="D8CDB8"/>
-                      </a:solidFill>
-                      <a:prstDash val="solid"/>
-                      <a:round/>
-                      <a:headEnd type="none" w="med" len="med"/>
-                      <a:tailEnd type="none" w="med" len="med"/>
-                    </a:lnT>
-                    <a:lnB w="9525" cap="flat" cmpd="sng" algn="ctr">
-                      <a:solidFill>
-                        <a:srgbClr val="D8CDB8"/>
-                      </a:solidFill>
-                      <a:prstDash val="solid"/>
-                      <a:round/>
-                      <a:headEnd type="none" w="med" len="med"/>
-                      <a:tailEnd type="none" w="med" len="med"/>
-                    </a:lnB>
-                    <a:solidFill>
-                      <a:srgbClr val="FFFFFF"/>
-                    </a:solidFill>
-                  </a:tcPr>
-                </a:tc>
-                <a:tc>
-                  <a:txBody>
-                    <a:bodyPr/>
-                    <a:lstStyle/>
-                    <a:p>
-                      <a:pPr algn="ctr" indent="0" marL="0">
-                        <a:buNone/>
-                      </a:pPr>
-                      <a:r>
-                        <a:rPr lang="en-US" sz="1600" dirty="0">
-                          <a:solidFill>
-                            <a:srgbClr val="1B1B1F"/>
-                          </a:solidFill>
-                          <a:latin typeface="Calibri" pitchFamily="34" charset="0"/>
-                          <a:ea typeface="Calibri" pitchFamily="34" charset="-122"/>
-                          <a:cs typeface="Calibri" pitchFamily="34" charset="-120"/>
-                        </a:rPr>
-                        <a:t>17</a:t>
-                      </a:r>
-                      <a:endParaRPr lang="en-US" sz="1600" dirty="0">
-                        <a:latin typeface="Calibri" charset="0"/>
-                        <a:ea typeface="Calibri" charset="0"/>
-                        <a:cs typeface="Calibri" charset="0"/>
-                      </a:endParaRPr>
-                    </a:p>
-                  </a:txBody>
-                  <a:tcPr marL="64008" marR="64008" marT="36576" marB="36576" anchor="ctr">
-                    <a:lnL w="9525" cap="flat" cmpd="sng" algn="ctr">
-                      <a:solidFill>
-                        <a:srgbClr val="D8CDB8"/>
-                      </a:solidFill>
-                      <a:prstDash val="solid"/>
-                      <a:round/>
-                      <a:headEnd type="none" w="med" len="med"/>
-                      <a:tailEnd type="none" w="med" len="med"/>
-                    </a:lnL>
-                    <a:lnR w="9525" cap="flat" cmpd="sng" algn="ctr">
-                      <a:solidFill>
-                        <a:srgbClr val="D8CDB8"/>
-                      </a:solidFill>
-                      <a:prstDash val="solid"/>
-                      <a:round/>
-                      <a:headEnd type="none" w="med" len="med"/>
-                      <a:tailEnd type="none" w="med" len="med"/>
-                    </a:lnR>
-                    <a:lnT w="9525" cap="flat" cmpd="sng" algn="ctr">
-                      <a:solidFill>
-                        <a:srgbClr val="D8CDB8"/>
-                      </a:solidFill>
-                      <a:prstDash val="solid"/>
-                      <a:round/>
-                      <a:headEnd type="none" w="med" len="med"/>
-                      <a:tailEnd type="none" w="med" len="med"/>
-                    </a:lnT>
-                    <a:lnB w="9525" cap="flat" cmpd="sng" algn="ctr">
-                      <a:solidFill>
-                        <a:srgbClr val="D8CDB8"/>
-                      </a:solidFill>
-                      <a:prstDash val="solid"/>
-                      <a:round/>
-                      <a:headEnd type="none" w="med" len="med"/>
-                      <a:tailEnd type="none" w="med" len="med"/>
-                    </a:lnB>
-                    <a:solidFill>
-                      <a:srgbClr val="FFFFFF"/>
-                    </a:solidFill>
-                  </a:tcPr>
-                </a:tc>
-                <a:tc>
-                  <a:txBody>
-                    <a:bodyPr/>
-                    <a:lstStyle/>
-                    <a:p>
-                      <a:pPr algn="ctr" indent="0" marL="0">
-                        <a:buNone/>
-                      </a:pPr>
-                      <a:r>
-                        <a:rPr lang="en-US" sz="1600" dirty="0">
-                          <a:solidFill>
-                            <a:srgbClr val="1B1B1F"/>
-                          </a:solidFill>
-                          <a:latin typeface="Calibri" pitchFamily="34" charset="0"/>
-                          <a:ea typeface="Calibri" pitchFamily="34" charset="-122"/>
-                          <a:cs typeface="Calibri" pitchFamily="34" charset="-120"/>
-                        </a:rPr>
-                        <a:t>25</a:t>
-                      </a:r>
-                      <a:endParaRPr lang="en-US" sz="1600" dirty="0">
-                        <a:latin typeface="Calibri" charset="0"/>
-                        <a:ea typeface="Calibri" charset="0"/>
-                        <a:cs typeface="Calibri" charset="0"/>
-                      </a:endParaRPr>
-                    </a:p>
-                  </a:txBody>
-                  <a:tcPr marL="64008" marR="64008" marT="36576" marB="36576" anchor="ctr">
-                    <a:lnL w="9525" cap="flat" cmpd="sng" algn="ctr">
-                      <a:solidFill>
-                        <a:srgbClr val="D8CDB8"/>
-                      </a:solidFill>
-                      <a:prstDash val="solid"/>
-                      <a:round/>
-                      <a:headEnd type="none" w="med" len="med"/>
-                      <a:tailEnd type="none" w="med" len="med"/>
-                    </a:lnL>
-                    <a:lnR w="9525" cap="flat" cmpd="sng" algn="ctr">
-                      <a:solidFill>
-                        <a:srgbClr val="D8CDB8"/>
-                      </a:solidFill>
-                      <a:prstDash val="solid"/>
-                      <a:round/>
-                      <a:headEnd type="none" w="med" len="med"/>
-                      <a:tailEnd type="none" w="med" len="med"/>
-                    </a:lnR>
-                    <a:lnT w="9525" cap="flat" cmpd="sng" algn="ctr">
-                      <a:solidFill>
-                        <a:srgbClr val="D8CDB8"/>
-                      </a:solidFill>
-                      <a:prstDash val="solid"/>
-                      <a:round/>
-                      <a:headEnd type="none" w="med" len="med"/>
-                      <a:tailEnd type="none" w="med" len="med"/>
-                    </a:lnT>
-                    <a:lnB w="9525" cap="flat" cmpd="sng" algn="ctr">
-                      <a:solidFill>
-                        <a:srgbClr val="D8CDB8"/>
-                      </a:solidFill>
-                      <a:prstDash val="solid"/>
-                      <a:round/>
-                      <a:headEnd type="none" w="med" len="med"/>
-                      <a:tailEnd type="none" w="med" len="med"/>
-                    </a:lnB>
-                    <a:solidFill>
-                      <a:srgbClr val="FFFFFF"/>
-                    </a:solidFill>
-                  </a:tcPr>
-                </a:tc>
-              </a:tr>
-            </a:tbl>
-          </a:graphicData>
-        </a:graphic>
-      </p:graphicFrame>
       <p:sp>
         <p:nvSpPr>
           <p:cNvPr id="25" name="Slide Number Placeholder 0"/>

</xml_diff>

<commit_message>
M11: Aufgaben ohne Werkzeug-Verrat umgebaut, Brute-Force-Liste W0-L2-04 als begründete Ausnahme (D18, Task 246)
- W1-L1-04 b): Rechenzentrum mit 10¹² /s → ≈ 1,3 · 10⁷ Jahre, e = 7 (Prüfwert W1-L1-04-b-v2, suchdauer, Zwilling).
- W6-L1-09 a): drei verschiedene Buchstaben → 26 · 25 · 24 = 15 600 (JS-Test und math.perm; Prüfwerte W6 nicht_abbildbar).
- W5-L2-04, W6-L2-09: Bob signiert; W5-L3-04: Bob fragt Alices öffentlichen Schlüssel an (L61).
- Specs W1/W5/W6 (Korrektur D18, §12), Präsentationsnotizen W1/W6 neu gebaut + PDFs, D18 in FACHLICHE_KORREKTUREN
  (mit Nachtrag zu D17), K11 UMBAU_OFFEN = [], Tests schaubild_rollen_getauscht und umbau_werte.

Co-Authored-By: Claude Opus 5.5 <noreply@anthropic.com>
Claude-Session: https://claude.ai/code/session_01JKXVQqFeKVmyQ9jfHw4db3
</commit_message>
<xml_diff>
--- a/materialien/Welt1_Bagdad/1_Praesentation/KR_W1_Praesentation_Bagdad.pptx
+++ b/materialien/Welt1_Bagdad/1_Praesentation/KR_W1_Praesentation_Bagdad.pptx
@@ -135,7 +135,7 @@
   <p:extLst>
     <p:ext uri="{521415D9-36F7-43E2-AB2F-B90AF26B5E84}">
       <p14:sectionLst xmlns:p14="http://schemas.microsoft.com/office/powerpoint/2010/main">
-        <p14:section name="DS 4 · Al-Kindis Handschrift" id="{b4a51f48-7de0-6383-5662-cb89679d755b}">
+        <p14:section name="DS 4 · Al-Kindis Handschrift" id="{70ff9f36-15f5-323c-fd19-4e70fc73cd15}">
           <p14:sldIdLst>
             <p14:sldId id="256"/>
             <p14:sldId id="257"/>
@@ -154,7 +154,7 @@
             <p14:sldId id="270"/>
           </p14:sldIdLst>
         </p14:section>
-        <p14:section name="DS 5 · Die Gegenmittel" id="{b81a1911-8d7b-f680-cbca-ad8d81400a58}">
+        <p14:section name="DS 5 · Die Gegenmittel" id="{5197ba36-e9ad-355c-0f83-fe788d4a2b12}">
           <p14:sldIdLst>
             <p14:sldId id="271"/>
             <p14:sldId id="272"/>
@@ -168,7 +168,7 @@
             <p14:sldId id="280"/>
           </p14:sldIdLst>
         </p14:section>
-        <p14:section name="DS 5 · Der Nomenklator" id="{ecaa6576-b63c-9f31-ef76-ab54b6e366fb}">
+        <p14:section name="DS 5 · Der Nomenklator" id="{61f70dd4-c46c-91f7-85f0-606d5ba8dbf9}">
           <p14:sldIdLst>
             <p14:sldId id="281"/>
             <p14:sldId id="282"/>
@@ -4127,7 +4127,7 @@
           <a:p>
             <a:r>
               <a:rPr lang="en-US" dirty="0"/>
-              <a:t>2 min. Rechnung: 4 · 10^26 : 10^9 : 3,2 · 10^7 s/Jahr ≈ 1,3 · 10^10 Jahre (Lab W1-L1-04). Spannung aufbauen: „Trotzdem werdet ihr in 25 Minuten einen solchen Text lesen.“ Notwendig, aber nicht hinreichend – Abitur-Formulierung für die Beurteilung (P7).</a:t>
+              <a:t>2 min. Rechnung: 4 · 10^26 : 10^9 : 3,2 · 10^7 s/Jahr ≈ 1,3 · 10^10 Jahre. Lab W1-L1-04 rechnet seit Korrektur D18 mit einem Rechenzentrum (10^12 /s → ≈ 1,3 · 10^7 Jahre) – nicht vorrechnen. Spannung aufbauen: „Trotzdem werdet ihr in 25 Minuten einen solchen Text lesen.“ Notwendig, aber nicht hinreichend – Abitur-Formulierung für die Beurteilung (P7).</a:t>
             </a:r>
             <a:endParaRPr lang="en-US" dirty="0"/>
           </a:p>

</xml_diff>

<commit_message>
Review-Fix 9: W1-L1-04 b) umgekehrt gefragt (Rechenleistung für ein Jahr, e = 19) – nicht aus den Werkzeuganzeigen ablesbar, D18 nachgezogen
Co-Authored-By: Claude Opus 5.5 <noreply@anthropic.com>
Claude-Session: https://claude.ai/code/session_01JKXVQqFeKVmyQ9jfHw4db3
</commit_message>
<xml_diff>
--- a/materialien/Welt1_Bagdad/1_Praesentation/KR_W1_Praesentation_Bagdad.pptx
+++ b/materialien/Welt1_Bagdad/1_Praesentation/KR_W1_Praesentation_Bagdad.pptx
@@ -135,7 +135,7 @@
   <p:extLst>
     <p:ext uri="{521415D9-36F7-43E2-AB2F-B90AF26B5E84}">
       <p14:sectionLst xmlns:p14="http://schemas.microsoft.com/office/powerpoint/2010/main">
-        <p14:section name="DS 4 · Al-Kindis Handschrift" id="{70ff9f36-15f5-323c-fd19-4e70fc73cd15}">
+        <p14:section name="DS 4 · Al-Kindis Handschrift" id="{5153e5b6-763c-7cca-7e8a-69f4ee670ad9}">
           <p14:sldIdLst>
             <p14:sldId id="256"/>
             <p14:sldId id="257"/>
@@ -154,7 +154,7 @@
             <p14:sldId id="270"/>
           </p14:sldIdLst>
         </p14:section>
-        <p14:section name="DS 5 · Die Gegenmittel" id="{5197ba36-e9ad-355c-0f83-fe788d4a2b12}">
+        <p14:section name="DS 5 · Die Gegenmittel" id="{bb548352-8074-d9a1-5ae4-94ef45d836e8}">
           <p14:sldIdLst>
             <p14:sldId id="271"/>
             <p14:sldId id="272"/>
@@ -168,7 +168,7 @@
             <p14:sldId id="280"/>
           </p14:sldIdLst>
         </p14:section>
-        <p14:section name="DS 5 · Der Nomenklator" id="{61f70dd4-c46c-91f7-85f0-606d5ba8dbf9}">
+        <p14:section name="DS 5 · Der Nomenklator" id="{93881753-c968-53ef-bc45-3c83b8d1f359}">
           <p14:sldIdLst>
             <p14:sldId id="281"/>
             <p14:sldId id="282"/>
@@ -4127,7 +4127,7 @@
           <a:p>
             <a:r>
               <a:rPr lang="en-US" dirty="0"/>
-              <a:t>2 min. Rechnung: 4 · 10^26 : 10^9 : 3,2 · 10^7 s/Jahr ≈ 1,3 · 10^10 Jahre. Lab W1-L1-04 rechnet seit Korrektur D18 mit einem Rechenzentrum (10^12 /s → ≈ 1,3 · 10^7 Jahre) – nicht vorrechnen. Spannung aufbauen: „Trotzdem werdet ihr in 25 Minuten einen solchen Text lesen.“ Notwendig, aber nicht hinreichend – Abitur-Formulierung für die Beurteilung (P7).</a:t>
+              <a:t>2 min. Rechnung: 4 · 10^26 : 10^9 : 3,2 · 10^7 s/Jahr ≈ 1,3 · 10^10 Jahre. Lab W1-L1-04 fragt seit Korrektur D18 umgekehrt nach der Rechenleistung für ein Jahr (≈ 1,3 · 10^19 /s) – nicht vorrechnen. Spannung aufbauen: „Trotzdem werdet ihr in 25 Minuten einen solchen Text lesen.“ Notwendig, aber nicht hinreichend – Abitur-Formulierung für die Beurteilung (P7).</a:t>
             </a:r>
             <a:endParaRPr lang="en-US" dirty="0"/>
           </a:p>

</xml_diff>